<commit_message>
Add English footer descriptions and speaker notes to each PPT slide.
</commit_message>
<xml_diff>
--- a/mayor-climate-presentation.pptx
+++ b/mayor-climate-presentation.pptx
@@ -949,20 +949,36 @@
           </a:bodyPr>
           <a:lstStyle/>
           <a:p>
-            <a:pPr marL="0" lvl="0" indent="0" algn="l" rtl="0">
-              <a:lnSpc>
-                <a:spcPct val="100000"/>
-              </a:lnSpc>
-              <a:spcBef>
-                <a:spcPts val="0"/>
-              </a:spcBef>
-              <a:spcAft>
-                <a:spcPts val="0"/>
-              </a:spcAft>
-              <a:buSzPts val="1400"/>
+            <a:pPr marL="0" indent="0" algn="l">
+              <a:lnSpc>
+                <a:spcPct val="115000"/>
+              </a:lnSpc>
               <a:buNone/>
             </a:pPr>
-            <a:endParaRPr/>
+            <a:r>
+              <a:rPr lang="en-US" sz="1200" dirty="0">
+                <a:latin typeface="Times New Roman"/>
+                <a:ea typeface="Times New Roman"/>
+                <a:cs typeface="Times New Roman"/>
+              </a:rPr>
+              <a:t>This slide is template instructions only—delete it before you submit the deck.</a:t>
+            </a:r>
+          </a:p>
+          <a:p>
+            <a:pPr marL="0" indent="0" algn="l">
+              <a:lnSpc>
+                <a:spcPct val="115000"/>
+              </a:lnSpc>
+              <a:buNone/>
+            </a:pPr>
+            <a:r>
+              <a:rPr lang="en-US" sz="1200" dirty="0">
+                <a:latin typeface="Times New Roman"/>
+                <a:ea typeface="Times New Roman"/>
+                <a:cs typeface="Times New Roman"/>
+              </a:rPr>
+              <a:t>The presentation covers Mayor Climate Game: a browser-based serious game for teaching urban energy layout and ventilation tradeoffs, based on N=10 pilot sessions collected in July 2026.</a:t>
+            </a:r>
           </a:p>
         </p:txBody>
       </p:sp>
@@ -1086,16 +1102,68 @@
           </a:bodyPr>
           <a:lstStyle/>
           <a:p>
-            <a:pPr marL="0" lvl="0" indent="0" algn="l" rtl="0">
-              <a:spcBef>
-                <a:spcPts val="0"/>
-              </a:spcBef>
-              <a:spcAft>
-                <a:spcPts val="0"/>
-              </a:spcAft>
+            <a:pPr marL="0" indent="0" algn="l">
+              <a:lnSpc>
+                <a:spcPct val="115000"/>
+              </a:lnSpc>
               <a:buNone/>
             </a:pPr>
-            <a:endParaRPr/>
+            <a:r>
+              <a:rPr lang="en-US" sz="1200" dirty="0">
+                <a:latin typeface="Times New Roman"/>
+                <a:ea typeface="Times New Roman"/>
+                <a:cs typeface="Times New Roman"/>
+              </a:rPr>
+              <a:t>This slide introduces the research scope and main question.</a:t>
+            </a:r>
+          </a:p>
+          <a:p>
+            <a:pPr marL="0" indent="0" algn="l">
+              <a:lnSpc>
+                <a:spcPct val="115000"/>
+              </a:lnSpc>
+              <a:buNone/>
+            </a:pPr>
+            <a:r>
+              <a:rPr lang="en-US" sz="1200" dirty="0">
+                <a:latin typeface="Times New Roman"/>
+                <a:ea typeface="Times New Roman"/>
+                <a:cs typeface="Times New Roman"/>
+              </a:rPr>
+              <a:t>Mayor Climate Game is a classroom-ready browser tool. Players place coal plants, wind turbines, and ground-source heat pumps on a city grid with a fixed budget.</a:t>
+            </a:r>
+          </a:p>
+          <a:p>
+            <a:pPr marL="0" indent="0" algn="l">
+              <a:lnSpc>
+                <a:spcPct val="115000"/>
+              </a:lnSpc>
+              <a:buNone/>
+            </a:pPr>
+            <a:r>
+              <a:rPr lang="en-US" sz="1200" dirty="0">
+                <a:latin typeface="Times New Roman"/>
+                <a:ea typeface="Times New Roman"/>
+                <a:cs typeface="Times New Roman"/>
+              </a:rPr>
+              <a:t>Research question: How does one play session shape facility choices and understanding of budget–carbon–ventilation tradeoffs?</a:t>
+            </a:r>
+          </a:p>
+          <a:p>
+            <a:pPr marL="0" indent="0" algn="l">
+              <a:lnSpc>
+                <a:spcPct val="115000"/>
+              </a:lnSpc>
+              <a:buNone/>
+            </a:pPr>
+            <a:r>
+              <a:rPr lang="en-US" sz="1200" dirty="0">
+                <a:latin typeface="Times New Roman"/>
+                <a:ea typeface="Times New Roman"/>
+                <a:cs typeface="Times New Roman"/>
+              </a:rPr>
+              <a:t>Hypothesis: after seeing live score and carbon feedback, participants avoid coal on ventilation-sensitive cells and answer the ventilation rule correctly.</a:t>
+            </a:r>
           </a:p>
         </p:txBody>
       </p:sp>
@@ -1202,16 +1270,68 @@
           </a:bodyPr>
           <a:lstStyle/>
           <a:p>
-            <a:pPr marL="0" lvl="0" indent="0" algn="l" rtl="0">
-              <a:spcBef>
-                <a:spcPts val="0"/>
-              </a:spcBef>
-              <a:spcAft>
-                <a:spcPts val="0"/>
-              </a:spcAft>
+            <a:pPr marL="0" indent="0" algn="l">
+              <a:lnSpc>
+                <a:spcPct val="115000"/>
+              </a:lnSpc>
               <a:buNone/>
             </a:pPr>
-            <a:endParaRPr/>
+            <a:r>
+              <a:rPr lang="en-US" sz="1200" dirty="0">
+                <a:latin typeface="Times New Roman"/>
+                <a:ea typeface="Times New Roman"/>
+                <a:cs typeface="Times New Roman"/>
+              </a:rPr>
+              <a:t>Urban areas face rising heat and growing cooling-related energy demand, which increases emissions pressure.</a:t>
+            </a:r>
+          </a:p>
+          <a:p>
+            <a:pPr marL="0" indent="0" algn="l">
+              <a:lnSpc>
+                <a:spcPct val="115000"/>
+              </a:lnSpc>
+              <a:buNone/>
+            </a:pPr>
+            <a:r>
+              <a:rPr lang="en-US" sz="1200" dirty="0">
+                <a:latin typeface="Times New Roman"/>
+                <a:ea typeface="Times New Roman"/>
+                <a:cs typeface="Times New Roman"/>
+              </a:rPr>
+              <a:t>Ventilation corridors can improve urban airflow—but only if energy facilities are not placed where they block wind pathways.</a:t>
+            </a:r>
+          </a:p>
+          <a:p>
+            <a:pPr marL="0" indent="0" algn="l">
+              <a:lnSpc>
+                <a:spcPct val="115000"/>
+              </a:lnSpc>
+              <a:buNone/>
+            </a:pPr>
+            <a:r>
+              <a:rPr lang="en-US" sz="1200" dirty="0">
+                <a:latin typeface="Times New Roman"/>
+                <a:ea typeface="Times New Roman"/>
+                <a:cs typeface="Times New Roman"/>
+              </a:rPr>
+              <a:t>Tools like CFD, WRF, and GIS are accurate but require expert training—too heavy for introductory learners.</a:t>
+            </a:r>
+          </a:p>
+          <a:p>
+            <a:pPr marL="0" indent="0" algn="l">
+              <a:lnSpc>
+                <a:spcPct val="115000"/>
+              </a:lnSpc>
+              <a:buNone/>
+            </a:pPr>
+            <a:r>
+              <a:rPr lang="en-US" sz="1200" dirty="0">
+                <a:latin typeface="Times New Roman"/>
+                <a:ea typeface="Times New Roman"/>
+                <a:cs typeface="Times New Roman"/>
+              </a:rPr>
+              <a:t>Serious games offer immediate feedback and automatically log every choice, making them useful for both teaching and exploratory research.</a:t>
+            </a:r>
           </a:p>
         </p:txBody>
       </p:sp>
@@ -1329,16 +1449,68 @@
           </a:bodyPr>
           <a:lstStyle/>
           <a:p>
-            <a:pPr marL="0" lvl="0" indent="0" algn="l" rtl="0">
-              <a:spcBef>
-                <a:spcPts val="0"/>
-              </a:spcBef>
-              <a:spcAft>
-                <a:spcPts val="0"/>
-              </a:spcAft>
+            <a:pPr marL="0" indent="0" algn="l">
+              <a:lnSpc>
+                <a:spcPct val="115000"/>
+              </a:lnSpc>
               <a:buNone/>
             </a:pPr>
-            <a:endParaRPr/>
+            <a:r>
+              <a:rPr lang="en-US" sz="1200" dirty="0">
+                <a:latin typeface="Times New Roman"/>
+                <a:ea typeface="Times New Roman"/>
+                <a:cs typeface="Times New Roman"/>
+              </a:rPr>
+              <a:t>IEA (2023) documents rising cooling demand and policy context for sustainable cooling.</a:t>
+            </a:r>
+          </a:p>
+          <a:p>
+            <a:pPr marL="0" indent="0" algn="l">
+              <a:lnSpc>
+                <a:spcPct val="115000"/>
+              </a:lnSpc>
+              <a:buNone/>
+            </a:pPr>
+            <a:r>
+              <a:rPr lang="en-US" sz="1200" dirty="0">
+                <a:latin typeface="Times New Roman"/>
+                <a:ea typeface="Times New Roman"/>
+                <a:cs typeface="Times New Roman"/>
+              </a:rPr>
+              <a:t>Zheng et al. (2022) and Guan et al. (2015) show why urban ventilation corridor planning and careful facility siting matter.</a:t>
+            </a:r>
+          </a:p>
+          <a:p>
+            <a:pPr marL="0" indent="0" algn="l">
+              <a:lnSpc>
+                <a:spcPct val="115000"/>
+              </a:lnSpc>
+              <a:buNone/>
+            </a:pPr>
+            <a:r>
+              <a:rPr lang="en-US" sz="1200" dirty="0">
+                <a:latin typeface="Times New Roman"/>
+                <a:ea typeface="Times New Roman"/>
+                <a:cs typeface="Times New Roman"/>
+              </a:rPr>
+              <a:t>Prior serious games (e.g., neighbourhood energy games, 2019) reveal preferences through logged player choices.</a:t>
+            </a:r>
+          </a:p>
+          <a:p>
+            <a:pPr marL="0" indent="0" algn="l">
+              <a:lnSpc>
+                <a:spcPct val="115000"/>
+              </a:lnSpc>
+              <a:buNone/>
+            </a:pPr>
+            <a:r>
+              <a:rPr lang="en-US" sz="1200" dirty="0">
+                <a:latin typeface="Times New Roman"/>
+                <a:ea typeface="Times New Roman"/>
+                <a:cs typeface="Times New Roman"/>
+              </a:rPr>
+              <a:t>Our gap: few lightweight browser prototypes combine play, visible metrics, and research-grade session logging in one package.</a:t>
+            </a:r>
           </a:p>
         </p:txBody>
       </p:sp>
@@ -1456,16 +1628,68 @@
           </a:bodyPr>
           <a:lstStyle/>
           <a:p>
-            <a:pPr marL="0" lvl="0" indent="0" algn="l" rtl="0">
-              <a:spcBef>
-                <a:spcPts val="0"/>
-              </a:spcBef>
-              <a:spcAft>
-                <a:spcPts val="0"/>
-              </a:spcAft>
+            <a:pPr marL="0" indent="0" algn="l">
+              <a:lnSpc>
+                <a:spcPct val="115000"/>
+              </a:lnSpc>
               <a:buNone/>
             </a:pPr>
-            <a:endParaRPr/>
+            <a:r>
+              <a:rPr lang="en-US" sz="1200" dirty="0">
+                <a:latin typeface="Times New Roman"/>
+                <a:ea typeface="Times New Roman"/>
+                <a:cs typeface="Times New Roman"/>
+              </a:rPr>
+              <a:t>The artifact is deployed on Vercel: a 12×12 grid, CNY 10 million budget, and three facility types (coal, wind, ground-source heat pump).</a:t>
+            </a:r>
+          </a:p>
+          <a:p>
+            <a:pPr marL="0" indent="0" algn="l">
+              <a:lnSpc>
+                <a:spcPct val="115000"/>
+              </a:lnSpc>
+              <a:buNone/>
+            </a:pPr>
+            <a:r>
+              <a:rPr lang="en-US" sz="1200" dirty="0">
+                <a:latin typeface="Times New Roman"/>
+                <a:ea typeface="Times New Roman"/>
+                <a:cs typeface="Times New Roman"/>
+              </a:rPr>
+              <a:t>Sample: N = 10 sessions—seven exported TXT reports plus three earlier pilot logs—each participant played one round in July 2026.</a:t>
+            </a:r>
+          </a:p>
+          <a:p>
+            <a:pPr marL="0" indent="0" algn="l">
+              <a:lnSpc>
+                <a:spcPct val="115000"/>
+              </a:lnSpc>
+              <a:buNone/>
+            </a:pPr>
+            <a:r>
+              <a:rPr lang="en-US" sz="1200" dirty="0">
+                <a:latin typeface="Times New Roman"/>
+                <a:ea typeface="Times New Roman"/>
+                <a:cs typeface="Times New Roman"/>
+              </a:rPr>
+              <a:t>Measures: two post-play survey items, final score, total carbon (tonnes CO₂e), and the full facility layout saved as JSON.</a:t>
+            </a:r>
+          </a:p>
+          <a:p>
+            <a:pPr marL="0" indent="0" algn="l">
+              <a:lnSpc>
+                <a:spcPct val="115000"/>
+              </a:lnSpc>
+              <a:buNone/>
+            </a:pPr>
+            <a:r>
+              <a:rPr lang="en-US" sz="1200" dirty="0">
+                <a:latin typeface="Times New Roman"/>
+                <a:ea typeface="Times New Roman"/>
+                <a:cs typeface="Times New Roman"/>
+              </a:rPr>
+              <a:t>Analysis is descriptive. The in-game microclimate model uses rule-based heuristics, not full CFD simulation.</a:t>
+            </a:r>
           </a:p>
         </p:txBody>
       </p:sp>
@@ -1583,16 +1807,100 @@
           </a:bodyPr>
           <a:lstStyle/>
           <a:p>
-            <a:pPr marL="0" lvl="0" indent="0" algn="l" rtl="0">
-              <a:spcBef>
-                <a:spcPts val="0"/>
-              </a:spcBef>
-              <a:spcAft>
-                <a:spcPts val="0"/>
-              </a:spcAft>
+            <a:pPr marL="0" indent="0" algn="l">
+              <a:lnSpc>
+                <a:spcPct val="115000"/>
+              </a:lnSpc>
               <a:buNone/>
             </a:pPr>
-            <a:endParaRPr/>
+            <a:r>
+              <a:rPr lang="en-US" sz="1200" dirty="0">
+                <a:latin typeface="Times New Roman"/>
+                <a:ea typeface="Times New Roman"/>
+                <a:cs typeface="Times New Roman"/>
+              </a:rPr>
+              <a:t>10 of 10 participants answered the ventilation survey item correctly.</a:t>
+            </a:r>
+          </a:p>
+          <a:p>
+            <a:pPr marL="0" indent="0" algn="l">
+              <a:lnSpc>
+                <a:spcPct val="115000"/>
+              </a:lnSpc>
+              <a:buNone/>
+            </a:pPr>
+            <a:r>
+              <a:rPr lang="en-US" sz="1200" dirty="0">
+                <a:latin typeface="Times New Roman"/>
+                <a:ea typeface="Times New Roman"/>
+                <a:cs typeface="Times New Roman"/>
+              </a:rPr>
+              <a:t>8 of 10 reported choosing coal to save budget; 2 chose zero-coal wind layouts instead.</a:t>
+            </a:r>
+          </a:p>
+          <a:p>
+            <a:pPr marL="0" indent="0" algn="l">
+              <a:lnSpc>
+                <a:spcPct val="115000"/>
+              </a:lnSpc>
+              <a:buNone/>
+            </a:pPr>
+            <a:r>
+              <a:rPr lang="en-US" sz="1200" dirty="0">
+                <a:latin typeface="Times New Roman"/>
+                <a:ea typeface="Times New Roman"/>
+                <a:cs typeface="Times New Roman"/>
+              </a:rPr>
+              <a:t>0 of 10 placed coal on wind outlets—none did.</a:t>
+            </a:r>
+          </a:p>
+          <a:p>
+            <a:pPr marL="0" indent="0" algn="l">
+              <a:lnSpc>
+                <a:spcPct val="115000"/>
+              </a:lnSpc>
+              <a:buNone/>
+            </a:pPr>
+            <a:r>
+              <a:rPr lang="en-US" sz="1200" dirty="0">
+                <a:latin typeface="Times New Roman"/>
+                <a:ea typeface="Times New Roman"/>
+                <a:cs typeface="Times New Roman"/>
+              </a:rPr>
+              <a:t>Scores ranged 51–88 (mean ≈ 80.2); carbon 0–1440 t (mean ≈ 273).</a:t>
+            </a:r>
+          </a:p>
+          <a:p>
+            <a:pPr marL="0" indent="0" algn="l">
+              <a:lnSpc>
+                <a:spcPct val="115000"/>
+              </a:lnSpc>
+              <a:buNone/>
+            </a:pPr>
+            <a:r>
+              <a:rPr lang="en-US" sz="1200" dirty="0">
+                <a:latin typeface="Times New Roman"/>
+                <a:ea typeface="Times New Roman"/>
+                <a:cs typeface="Times New Roman"/>
+              </a:rPr>
+              <a:t>Pattern: lower carbon (0–120 t, n=7) co-occurred with scores 84–88; higher carbon (240–1440 t, n=3) with scores 51–81.</a:t>
+            </a:r>
+          </a:p>
+          <a:p>
+            <a:pPr marL="0" indent="0" algn="l">
+              <a:lnSpc>
+                <a:spcPct val="115000"/>
+              </a:lnSpc>
+              <a:buNone/>
+            </a:pPr>
+            <a:r>
+              <a:rPr lang="en-US" sz="1200" dirty="0">
+                <a:latin typeface="Times New Roman"/>
+                <a:ea typeface="Times New Roman"/>
+                <a:cs typeface="Times New Roman"/>
+              </a:rPr>
+              <a:t>Live demo: mayor-climate-game.vercel.app</a:t>
+            </a:r>
           </a:p>
         </p:txBody>
       </p:sp>
@@ -1710,16 +2018,68 @@
           </a:bodyPr>
           <a:lstStyle/>
           <a:p>
-            <a:pPr marL="0" lvl="0" indent="0" algn="l" rtl="0">
-              <a:spcBef>
-                <a:spcPts val="0"/>
-              </a:spcBef>
-              <a:spcAft>
-                <a:spcPts val="0"/>
-              </a:spcAft>
+            <a:pPr marL="0" indent="0" algn="l">
+              <a:lnSpc>
+                <a:spcPct val="115000"/>
+              </a:lnSpc>
               <a:buNone/>
             </a:pPr>
-            <a:endParaRPr/>
+            <a:r>
+              <a:rPr lang="en-US" sz="1200" dirty="0">
+                <a:latin typeface="Times New Roman"/>
+                <a:ea typeface="Times New Roman"/>
+                <a:cs typeface="Times New Roman"/>
+              </a:rPr>
+              <a:t>Findings partially support the hypothesis: ventilation knowledge was strong and no participant blocked ventilation outlets.</a:t>
+            </a:r>
+          </a:p>
+          <a:p>
+            <a:pPr marL="0" indent="0" algn="l">
+              <a:lnSpc>
+                <a:spcPct val="115000"/>
+              </a:lnSpc>
+              <a:buNone/>
+            </a:pPr>
+            <a:r>
+              <a:rPr lang="en-US" sz="1200" dirty="0">
+                <a:latin typeface="Times New Roman"/>
+                <a:ea typeface="Times New Roman"/>
+                <a:cs typeface="Times New Roman"/>
+              </a:rPr>
+              <a:t>Budget pressure remains salient—most players cited cost—but two still built zero-coal wind layouts.</a:t>
+            </a:r>
+          </a:p>
+          <a:p>
+            <a:pPr marL="0" indent="0" algn="l">
+              <a:lnSpc>
+                <a:spcPct val="115000"/>
+              </a:lnSpc>
+              <a:buNone/>
+            </a:pPr>
+            <a:r>
+              <a:rPr lang="en-US" sz="1200" dirty="0">
+                <a:latin typeface="Times New Roman"/>
+                <a:ea typeface="Times New Roman"/>
+                <a:cs typeface="Times New Roman"/>
+              </a:rPr>
+              <a:t>Carbon outcomes varied sharply by facility mix, not by stated budget motivation alone.</a:t>
+            </a:r>
+          </a:p>
+          <a:p>
+            <a:pPr marL="0" indent="0" algn="l">
+              <a:lnSpc>
+                <a:spcPct val="115000"/>
+              </a:lnSpc>
+              <a:buNone/>
+            </a:pPr>
+            <a:r>
+              <a:rPr lang="en-US" sz="1200" dirty="0">
+                <a:latin typeface="Times New Roman"/>
+                <a:ea typeface="Times New Roman"/>
+                <a:cs typeface="Times New Roman"/>
+              </a:rPr>
+              <a:t>A short browser session can make abstract cost–carbon–ventilation tradeoffs concrete for classroom discussion.</a:t>
+            </a:r>
           </a:p>
         </p:txBody>
       </p:sp>
@@ -1837,16 +2197,52 @@
           </a:bodyPr>
           <a:lstStyle/>
           <a:p>
-            <a:pPr marL="0" lvl="0" indent="0" algn="l" rtl="0">
-              <a:spcBef>
-                <a:spcPts val="0"/>
-              </a:spcBef>
-              <a:spcAft>
-                <a:spcPts val="0"/>
-              </a:spcAft>
+            <a:pPr marL="0" indent="0" algn="l">
+              <a:lnSpc>
+                <a:spcPct val="115000"/>
+              </a:lnSpc>
               <a:buNone/>
             </a:pPr>
-            <a:endParaRPr/>
+            <a:r>
+              <a:rPr lang="en-US" sz="1200" dirty="0">
+                <a:latin typeface="Times New Roman"/>
+                <a:ea typeface="Times New Roman"/>
+                <a:cs typeface="Times New Roman"/>
+              </a:rPr>
+              <a:t>Answer to the research question: the game supports declarative ventilation understanding and safer siting behavior in this pilot.</a:t>
+            </a:r>
+          </a:p>
+          <a:p>
+            <a:pPr marL="0" indent="0" algn="l">
+              <a:lnSpc>
+                <a:spcPct val="115000"/>
+              </a:lnSpc>
+              <a:buNone/>
+            </a:pPr>
+            <a:r>
+              <a:rPr lang="en-US" sz="1200" dirty="0">
+                <a:latin typeface="Times New Roman"/>
+                <a:ea typeface="Times New Roman"/>
+                <a:cs typeface="Times New Roman"/>
+              </a:rPr>
+              <a:t>Limitations: N=10, simplified rule-based model, exploratory design—not confirmatory statistical evidence.</a:t>
+            </a:r>
+          </a:p>
+          <a:p>
+            <a:pPr marL="0" indent="0" algn="l">
+              <a:lnSpc>
+                <a:spcPct val="115000"/>
+              </a:lnSpc>
+              <a:buNone/>
+            </a:pPr>
+            <a:r>
+              <a:rPr lang="en-US" sz="1200" dirty="0">
+                <a:latin typeface="Times New Roman"/>
+                <a:ea typeface="Times New Roman"/>
+                <a:cs typeface="Times New Roman"/>
+              </a:rPr>
+              <a:t>Future work: pre-register outcomes, expand sample size, and test alternative in-game advisory messages.</a:t>
+            </a:r>
           </a:p>
         </p:txBody>
       </p:sp>
@@ -1964,16 +2360,36 @@
           </a:bodyPr>
           <a:lstStyle/>
           <a:p>
-            <a:pPr marL="0" lvl="0" indent="0" algn="l" rtl="0">
-              <a:spcBef>
-                <a:spcPts val="0"/>
-              </a:spcBef>
-              <a:spcAft>
-                <a:spcPts val="0"/>
-              </a:spcAft>
+            <a:pPr marL="0" indent="0" algn="l">
+              <a:lnSpc>
+                <a:spcPct val="115000"/>
+              </a:lnSpc>
               <a:buNone/>
             </a:pPr>
-            <a:endParaRPr/>
+            <a:r>
+              <a:rPr lang="en-US" sz="1200" dirty="0">
+                <a:latin typeface="Times New Roman"/>
+                <a:ea typeface="Times New Roman"/>
+                <a:cs typeface="Times New Roman"/>
+              </a:rPr>
+              <a:t>These references anchor the cooling-demand context, ventilation corridor literature, and serious-game methodology.</a:t>
+            </a:r>
+          </a:p>
+          <a:p>
+            <a:pPr marL="0" indent="0" algn="l">
+              <a:lnSpc>
+                <a:spcPct val="115000"/>
+              </a:lnSpc>
+              <a:buNone/>
+            </a:pPr>
+            <a:r>
+              <a:rPr lang="en-US" sz="1200" dirty="0">
+                <a:latin typeface="Times New Roman"/>
+                <a:ea typeface="Times New Roman"/>
+                <a:cs typeface="Times New Roman"/>
+              </a:rPr>
+              <a:t>Full bibliography and the working paper are in the project repository: github.com/HYH-SZ/mayor-climate-game.</a:t>
+            </a:r>
           </a:p>
         </p:txBody>
       </p:sp>
@@ -10580,6 +10996,62 @@
           </a:p>
         </p:txBody>
       </p:sp>
+      <p:sp>
+        <p:nvSpPr>
+          <p:cNvPr id="999" name="Footer Note"/>
+          <p:cNvSpPr txBox="1"/>
+          <p:nvPr/>
+        </p:nvSpPr>
+        <p:spPr>
+          <a:xfrm>
+            <a:off x="0" y="5047864"/>
+            <a:ext cx="9144000" cy="104400"/>
+          </a:xfrm>
+          <a:prstGeom prst="rect">
+            <a:avLst/>
+          </a:prstGeom>
+          <a:gradFill>
+            <a:gsLst>
+              <a:gs pos="0">
+                <a:srgbClr val="DF02FC"/>
+              </a:gs>
+              <a:gs pos="50000">
+                <a:srgbClr val="2E3BEE"/>
+              </a:gs>
+              <a:gs pos="100000">
+                <a:srgbClr val="10E4DF"/>
+              </a:gs>
+            </a:gsLst>
+            <a:lin ang="4800126" scaled="0"/>
+          </a:gradFill>
+          <a:ln>
+            <a:noFill/>
+          </a:ln>
+        </p:spPr>
+        <p:txBody>
+          <a:bodyPr wrap="square" lIns="68569" tIns="34275" rIns="68569" bIns="34275" anchor="ctr">
+            <a:normAutofit/>
+          </a:bodyPr>
+          <a:lstStyle/>
+          <a:p>
+            <a:pPr algn="ctr">
+              <a:lnSpc>
+                <a:spcPct val="90000"/>
+              </a:lnSpc>
+            </a:pPr>
+            <a:r>
+              <a:rPr lang="en-US" sz="1000" dirty="0">
+                <a:solidFill>
+                  <a:schemeClr val="lt1"/>
+                </a:solidFill>
+                <a:latin typeface="Times New Roman"/>
+                <a:ea typeface="Times New Roman"/>
+              </a:rPr>
+              <a:t>Note: This instruction slide should be deleted before submission. The deck presents Mayor Climate Game—a browser prototype for teaching urban energy and ventilation tradeoffs.</a:t>
+            </a:r>
+          </a:p>
+        </p:txBody>
+      </p:sp>
     </p:spTree>
   </p:cSld>
   <p:clrMapOvr>
@@ -10728,12 +11200,21 @@
           </a:bodyPr>
           <a:lstStyle/>
           <a:p>
-            <a:pPr algn="ctr"/>
-            <a:endParaRPr sz="1350">
-              <a:solidFill>
-                <a:schemeClr val="lt1"/>
-              </a:solidFill>
-            </a:endParaRPr>
+            <a:pPr algn="ctr">
+              <a:lnSpc>
+                <a:spcPct val="90000"/>
+              </a:lnSpc>
+            </a:pPr>
+            <a:r>
+              <a:rPr lang="en-US" sz="1000" dirty="0">
+                <a:solidFill>
+                  <a:schemeClr val="lt1"/>
+                </a:solidFill>
+                <a:latin typeface="Times New Roman"/>
+                <a:ea typeface="Times New Roman"/>
+              </a:rPr>
+              <a:t>Takeaway: References cover sustainable cooling, urban ventilation planning, and serious-game methods. Full bibliography and paper: github.com/HYH-SZ/mayor-climate-game.</a:t>
+            </a:r>
           </a:p>
         </p:txBody>
       </p:sp>
@@ -12174,6 +12655,62 @@
           </a:p>
         </p:txBody>
       </p:sp>
+      <p:sp>
+        <p:nvSpPr>
+          <p:cNvPr id="999" name="Footer Note"/>
+          <p:cNvSpPr txBox="1"/>
+          <p:nvPr/>
+        </p:nvSpPr>
+        <p:spPr>
+          <a:xfrm>
+            <a:off x="0" y="5047864"/>
+            <a:ext cx="9144000" cy="104400"/>
+          </a:xfrm>
+          <a:prstGeom prst="rect">
+            <a:avLst/>
+          </a:prstGeom>
+          <a:gradFill>
+            <a:gsLst>
+              <a:gs pos="0">
+                <a:srgbClr val="DF02FC"/>
+              </a:gs>
+              <a:gs pos="50000">
+                <a:srgbClr val="2E3BEE"/>
+              </a:gs>
+              <a:gs pos="100000">
+                <a:srgbClr val="10E4DF"/>
+              </a:gs>
+            </a:gsLst>
+            <a:lin ang="4800126" scaled="0"/>
+          </a:gradFill>
+          <a:ln>
+            <a:noFill/>
+          </a:ln>
+        </p:spPr>
+        <p:txBody>
+          <a:bodyPr wrap="square" lIns="68569" tIns="34275" rIns="68569" bIns="34275" anchor="ctr">
+            <a:normAutofit/>
+          </a:bodyPr>
+          <a:lstStyle/>
+          <a:p>
+            <a:pPr algn="ctr">
+              <a:lnSpc>
+                <a:spcPct val="90000"/>
+              </a:lnSpc>
+            </a:pPr>
+            <a:r>
+              <a:rPr lang="en-US" sz="1000" dirty="0">
+                <a:solidFill>
+                  <a:schemeClr val="lt1"/>
+                </a:solidFill>
+                <a:latin typeface="Times New Roman"/>
+                <a:ea typeface="Times New Roman"/>
+              </a:rPr>
+              <a:t>Thank you for your attention. I welcome questions about the live demo (mayor-climate-game.vercel.app), data collection, or plans for a larger study.</a:t>
+            </a:r>
+          </a:p>
+        </p:txBody>
+      </p:sp>
     </p:spTree>
     <p:extLst>
       <p:ext uri="{BB962C8B-B14F-4D97-AF65-F5344CB8AC3E}">
@@ -12959,6 +13496,62 @@
           </a:p>
         </p:txBody>
       </p:sp>
+      <p:sp>
+        <p:nvSpPr>
+          <p:cNvPr id="999" name="Footer Note"/>
+          <p:cNvSpPr txBox="1"/>
+          <p:nvPr/>
+        </p:nvSpPr>
+        <p:spPr>
+          <a:xfrm>
+            <a:off x="0" y="5047864"/>
+            <a:ext cx="9144000" cy="104400"/>
+          </a:xfrm>
+          <a:prstGeom prst="rect">
+            <a:avLst/>
+          </a:prstGeom>
+          <a:gradFill>
+            <a:gsLst>
+              <a:gs pos="0">
+                <a:srgbClr val="DF02FC"/>
+              </a:gs>
+              <a:gs pos="50000">
+                <a:srgbClr val="2E3BEE"/>
+              </a:gs>
+              <a:gs pos="100000">
+                <a:srgbClr val="10E4DF"/>
+              </a:gs>
+            </a:gsLst>
+            <a:lin ang="4800126" scaled="0"/>
+          </a:gradFill>
+          <a:ln>
+            <a:noFill/>
+          </a:ln>
+        </p:spPr>
+        <p:txBody>
+          <a:bodyPr wrap="square" lIns="68569" tIns="34275" rIns="68569" bIns="34275" anchor="ctr">
+            <a:normAutofit/>
+          </a:bodyPr>
+          <a:lstStyle/>
+          <a:p>
+            <a:pPr algn="ctr">
+              <a:lnSpc>
+                <a:spcPct val="90000"/>
+              </a:lnSpc>
+            </a:pPr>
+            <a:r>
+              <a:rPr lang="en-US" sz="1000" dirty="0">
+                <a:solidFill>
+                  <a:schemeClr val="lt1"/>
+                </a:solidFill>
+                <a:latin typeface="Times New Roman"/>
+                <a:ea typeface="Times New Roman"/>
+              </a:rPr>
+              <a:t>Takeaway: I present Mayor Climate Game—a browser serious game where players learn how city energy choices affect budget, carbon emissions, and urban ventilation (Hu Yunhan; advisor: Lawted Wu).</a:t>
+            </a:r>
+          </a:p>
+        </p:txBody>
+      </p:sp>
     </p:spTree>
     <p:extLst>
       <p:ext uri="{BB962C8B-B14F-4D97-AF65-F5344CB8AC3E}">
@@ -13088,12 +13681,21 @@
           </a:bodyPr>
           <a:lstStyle/>
           <a:p>
-            <a:pPr algn="ctr"/>
-            <a:endParaRPr sz="1350">
-              <a:solidFill>
-                <a:schemeClr val="lt1"/>
-              </a:solidFill>
-            </a:endParaRPr>
+            <a:pPr algn="ctr">
+              <a:lnSpc>
+                <a:spcPct val="90000"/>
+              </a:lnSpc>
+            </a:pPr>
+            <a:r>
+              <a:rPr lang="en-US" sz="1000" dirty="0">
+                <a:solidFill>
+                  <a:schemeClr val="lt1"/>
+                </a:solidFill>
+                <a:latin typeface="Times New Roman"/>
+                <a:ea typeface="Times New Roman"/>
+              </a:rPr>
+              <a:t>Takeaway: We ask whether one play session helps learners understand budget–carbon–ventilation tradeoffs—and whether live feedback leads them to avoid blocking airflow with coal plants.</a:t>
+            </a:r>
           </a:p>
         </p:txBody>
       </p:sp>
@@ -13849,12 +14451,21 @@
           </a:bodyPr>
           <a:lstStyle/>
           <a:p>
-            <a:pPr algn="ctr"/>
-            <a:endParaRPr sz="1350">
-              <a:solidFill>
-                <a:schemeClr val="lt1"/>
-              </a:solidFill>
-            </a:endParaRPr>
+            <a:pPr algn="ctr">
+              <a:lnSpc>
+                <a:spcPct val="90000"/>
+              </a:lnSpc>
+            </a:pPr>
+            <a:r>
+              <a:rPr lang="en-US" sz="1000" dirty="0">
+                <a:solidFill>
+                  <a:schemeClr val="lt1"/>
+                </a:solidFill>
+                <a:latin typeface="Times New Roman"/>
+                <a:ea typeface="Times New Roman"/>
+              </a:rPr>
+              <a:t>Takeaway: Cities must balance cheap energy, low carbon, and good airflow. Professional CFD tools are powerful but too hard for beginners; this game makes tradeoffs visible through play.</a:t>
+            </a:r>
           </a:p>
         </p:txBody>
       </p:sp>
@@ -14631,12 +15242,21 @@
           </a:bodyPr>
           <a:lstStyle/>
           <a:p>
-            <a:pPr algn="ctr"/>
-            <a:endParaRPr sz="1350">
-              <a:solidFill>
-                <a:schemeClr val="lt1"/>
-              </a:solidFill>
-            </a:endParaRPr>
+            <a:pPr algn="ctr">
+              <a:lnSpc>
+                <a:spcPct val="90000"/>
+              </a:lnSpc>
+            </a:pPr>
+            <a:r>
+              <a:rPr lang="en-US" sz="1000" dirty="0">
+                <a:solidFill>
+                  <a:schemeClr val="lt1"/>
+                </a:solidFill>
+                <a:latin typeface="Times New Roman"/>
+                <a:ea typeface="Times New Roman"/>
+              </a:rPr>
+              <a:t>Takeaway: Cooling demand is rising and ventilation corridors matter, yet few classroom-ready browser tools combine playable simulation, live metrics, and automatic research logging.</a:t>
+            </a:r>
           </a:p>
         </p:txBody>
       </p:sp>
@@ -15413,12 +16033,21 @@
           </a:bodyPr>
           <a:lstStyle/>
           <a:p>
-            <a:pPr algn="ctr"/>
-            <a:endParaRPr sz="1350">
-              <a:solidFill>
-                <a:schemeClr val="lt1"/>
-              </a:solidFill>
-            </a:endParaRPr>
+            <a:pPr algn="ctr">
+              <a:lnSpc>
+                <a:spcPct val="90000"/>
+              </a:lnSpc>
+            </a:pPr>
+            <a:r>
+              <a:rPr lang="en-US" sz="1000" dirty="0">
+                <a:solidFill>
+                  <a:schemeClr val="lt1"/>
+                </a:solidFill>
+                <a:latin typeface="Times New Roman"/>
+                <a:ea typeface="Times New Roman"/>
+              </a:rPr>
+              <a:t>Takeaway: N = 10 one-round sessions (July 2026). Players placed facilities on a 12×12 grid; we logged scores, carbon totals, survey answers, and full layout JSON for each session.</a:t>
+            </a:r>
           </a:p>
         </p:txBody>
       </p:sp>
@@ -16195,12 +16824,21 @@
           </a:bodyPr>
           <a:lstStyle/>
           <a:p>
-            <a:pPr algn="ctr"/>
-            <a:endParaRPr sz="1350">
-              <a:solidFill>
-                <a:schemeClr val="lt1"/>
-              </a:solidFill>
-            </a:endParaRPr>
+            <a:pPr algn="ctr">
+              <a:lnSpc>
+                <a:spcPct val="90000"/>
+              </a:lnSpc>
+            </a:pPr>
+            <a:r>
+              <a:rPr lang="en-US" sz="1000" dirty="0">
+                <a:solidFill>
+                  <a:schemeClr val="lt1"/>
+                </a:solidFill>
+                <a:latin typeface="Times New Roman"/>
+                <a:ea typeface="Times New Roman"/>
+              </a:rPr>
+              <a:t>Takeaway: 10/10 answered ventilation correctly; 0/10 blocked outlets. Carbon ranged 0–1440 t—clean layouts scored 84–88; heavy-coal layouts scored 51–81.</a:t>
+            </a:r>
           </a:p>
         </p:txBody>
       </p:sp>
@@ -16996,12 +17634,21 @@
           </a:bodyPr>
           <a:lstStyle/>
           <a:p>
-            <a:pPr algn="ctr"/>
-            <a:endParaRPr sz="1350">
-              <a:solidFill>
-                <a:schemeClr val="lt1"/>
-              </a:solidFill>
-            </a:endParaRPr>
+            <a:pPr algn="ctr">
+              <a:lnSpc>
+                <a:spcPct val="90000"/>
+              </a:lnSpc>
+            </a:pPr>
+            <a:r>
+              <a:rPr lang="en-US" sz="1000" dirty="0">
+                <a:solidFill>
+                  <a:schemeClr val="lt1"/>
+                </a:solidFill>
+                <a:latin typeface="Times New Roman"/>
+                <a:ea typeface="Times New Roman"/>
+              </a:rPr>
+              <a:t>Takeaway: Budget pressure was common (8/10), but facility mix—not stated motivation alone—drove carbon outcomes. Short browser play can teach tradeoffs textbooks alone cannot show.</a:t>
+            </a:r>
           </a:p>
         </p:txBody>
       </p:sp>
@@ -17781,12 +18428,21 @@
           </a:bodyPr>
           <a:lstStyle/>
           <a:p>
-            <a:pPr algn="ctr"/>
-            <a:endParaRPr sz="1350">
-              <a:solidFill>
-                <a:schemeClr val="lt1"/>
-              </a:solidFill>
-            </a:endParaRPr>
+            <a:pPr algn="ctr">
+              <a:lnSpc>
+                <a:spcPct val="90000"/>
+              </a:lnSpc>
+            </a:pPr>
+            <a:r>
+              <a:rPr lang="en-US" sz="1000" dirty="0">
+                <a:solidFill>
+                  <a:schemeClr val="lt1"/>
+                </a:solidFill>
+                <a:latin typeface="Times New Roman"/>
+                <a:ea typeface="Times New Roman"/>
+              </a:rPr>
+              <a:t>Takeaway: The pilot supports ventilation learning and safer siting, but N=10 limits generalization. Next: pre-register outcomes, expand the sample, and test advisory conditions.</a:t>
+            </a:r>
           </a:p>
         </p:txBody>
       </p:sp>

</xml_diff>

<commit_message>
Update all materials to N=15 sessions including 5 pre/post TXT exports.
</commit_message>
<xml_diff>
--- a/mayor-climate-presentation.pptx
+++ b/mayor-climate-presentation.pptx
@@ -977,7 +977,7 @@
                 <a:ea typeface="Times New Roman"/>
                 <a:cs typeface="Times New Roman"/>
               </a:rPr>
-              <a:t>The presentation covers Mayor Climate Game: a browser-based serious game for teaching urban energy layout and ventilation tradeoffs, based on N=10 pilot sessions collected in July 2026.</a:t>
+              <a:t>The presentation covers Mayor Climate Game, based on N=15 pilot sessions collected in July 2026 (including 5 pre/post exports).</a:t>
             </a:r>
           </a:p>
         </p:txBody>
@@ -1656,7 +1656,7 @@
                 <a:ea typeface="Times New Roman"/>
                 <a:cs typeface="Times New Roman"/>
               </a:rPr>
-              <a:t>Sample: N = 10 sessions—seven exported TXT reports plus three earlier pilot logs—each participant played one round in July 2026.</a:t>
+              <a:t>Sample: N = 15 sessions—10 earlier exports plus 5 pre/post TXT reports—in July 2026.</a:t>
             </a:r>
           </a:p>
           <a:p>
@@ -1672,7 +1672,7 @@
                 <a:ea typeface="Times New Roman"/>
                 <a:cs typeface="Times New Roman"/>
               </a:rPr>
-              <a:t>Measures: two post-play survey items, final score, total carbon (tonnes CO₂e), and the full facility layout saved as JSON.</a:t>
+              <a:t>Measures: pre/post cognition and attitude items, gameplay survey, score, carbon, and layout JSON.</a:t>
             </a:r>
           </a:p>
           <a:p>
@@ -1819,7 +1819,7 @@
                 <a:ea typeface="Times New Roman"/>
                 <a:cs typeface="Times New Roman"/>
               </a:rPr>
-              <a:t>10 of 10 participants answered the ventilation survey item correctly.</a:t>
+              <a:t>15 of 15 participants answered the ventilation survey item correctly.</a:t>
             </a:r>
           </a:p>
           <a:p>
@@ -1835,7 +1835,7 @@
                 <a:ea typeface="Times New Roman"/>
                 <a:cs typeface="Times New Roman"/>
               </a:rPr>
-              <a:t>8 of 10 reported choosing coal to save budget; 2 chose zero-coal wind layouts instead.</a:t>
+              <a:t>11 of 15 reported choosing coal to save budget; 4 chose zero-coal wind layouts instead.</a:t>
             </a:r>
           </a:p>
           <a:p>
@@ -1851,7 +1851,7 @@
                 <a:ea typeface="Times New Roman"/>
                 <a:cs typeface="Times New Roman"/>
               </a:rPr>
-              <a:t>0 of 10 placed coal on wind outlets—none did.</a:t>
+              <a:t>0 of 15 placed coal on wind outlets—none did.</a:t>
             </a:r>
           </a:p>
           <a:p>
@@ -1867,7 +1867,7 @@
                 <a:ea typeface="Times New Roman"/>
                 <a:cs typeface="Times New Roman"/>
               </a:rPr>
-              <a:t>Scores ranged 51–88 (mean ≈ 80.2); carbon 0–1440 t (mean ≈ 273).</a:t>
+              <a:t>Scores ranged 51–88 (mean ≈ 76.9); carbon 0–1440 t (mean ≈ 438).</a:t>
             </a:r>
           </a:p>
           <a:p>
@@ -1883,7 +1883,23 @@
                 <a:ea typeface="Times New Roman"/>
                 <a:cs typeface="Times New Roman"/>
               </a:rPr>
-              <a:t>Pattern: lower carbon (0–120 t, n=7) co-occurred with scores 84–88; higher carbon (240–1440 t, n=3) with scores 51–81.</a:t>
+              <a:t>Low carbon (0–120 t, n=9): scores mostly 84–88; high carbon (240–1440 t, n=6): scores 51–81</a:t>
+            </a:r>
+          </a:p>
+          <a:p>
+            <a:pPr marL="0" indent="0" algn="l">
+              <a:lnSpc>
+                <a:spcPct val="115000"/>
+              </a:lnSpc>
+              <a:buNone/>
+            </a:pPr>
+            <a:r>
+              <a:rPr lang="en-US" sz="1200" dirty="0">
+                <a:latin typeface="Times New Roman"/>
+                <a:ea typeface="Times New Roman"/>
+                <a:cs typeface="Times New Roman"/>
+              </a:rPr>
+              <a:t>Pre/post subset (n=5): mean cognition 3 → 3 (no change).</a:t>
             </a:r>
           </a:p>
           <a:p>
@@ -2225,7 +2241,7 @@
                 <a:ea typeface="Times New Roman"/>
                 <a:cs typeface="Times New Roman"/>
               </a:rPr>
-              <a:t>Limitations: N=10, simplified rule-based model, exploratory design—not confirmatory statistical evidence.</a:t>
+              <a:t>Limitations: N=15, simplified rule-based model, exploratory design—not confirmatory statistical evidence.</a:t>
             </a:r>
           </a:p>
           <a:p>
@@ -16046,7 +16062,7 @@
                 <a:latin typeface="Times New Roman"/>
                 <a:ea typeface="Times New Roman"/>
               </a:rPr>
-              <a:t>Takeaway: N = 10 one-round sessions (July 2026). Players placed facilities on a 12×12 grid; we logged scores, carbon totals, survey answers, and full layout JSON for each session.</a:t>
+              <a:t>Takeaway: N = 15 one-round sessions (July 2026). Players placed facilities on a 12×12 grid; we logged scores, carbon totals, survey answers, and full layout JSON for each session.</a:t>
             </a:r>
           </a:p>
         </p:txBody>
@@ -16634,7 +16650,7 @@
                 <a:ea typeface="Times New Roman"/>
                 <a:cs typeface="Times New Roman"/>
               </a:rPr>
-              <a:t>Sample: N = 10 sessions (7 TXT exports + 3 pilot logs), July 2026, one round each</a:t>
+              <a:t>Sample: N = 15 sessions (10 earlier + 5 pre/post TXT exports), July 2026</a:t>
             </a:r>
           </a:p>
           <a:p>
@@ -16650,7 +16666,7 @@
                 <a:ea typeface="Times New Roman"/>
                 <a:cs typeface="Times New Roman"/>
               </a:rPr>
-              <a:t>Measures: 2 post-play survey items + final score, carbon (t CO₂e), and layout JSON</a:t>
+              <a:t>Measures: pre/post cognition (4 items) + attitude (2) + gameplay survey + score, carbon, layout JSON</a:t>
             </a:r>
           </a:p>
           <a:p>
@@ -16837,7 +16853,7 @@
                 <a:latin typeface="Times New Roman"/>
                 <a:ea typeface="Times New Roman"/>
               </a:rPr>
-              <a:t>Takeaway: 10/10 answered ventilation correctly; 0/10 blocked outlets. Carbon ranged 0–1440 t—clean layouts scored 84–88; heavy-coal layouts scored 51–81.</a:t>
+              <a:t>Takeaway: 15/15 answered ventilation correctly; 0/15 blocked outlets. Carbon 0–1440 t. Pre/post n=5: cognition stayed 3/4.</a:t>
             </a:r>
           </a:p>
         </p:txBody>
@@ -17412,7 +17428,7 @@
                 <a:ea typeface="Times New Roman"/>
                 <a:cs typeface="Times New Roman"/>
               </a:rPr>
-              <a:t>10/10 answered the ventilation item correctly; 8/10 reported choosing coal to save budget</a:t>
+              <a:t>15/15 answered the ventilation item correctly; 11/15 reported choosing coal to save budget</a:t>
             </a:r>
           </a:p>
           <a:p>
@@ -17428,7 +17444,7 @@
                 <a:ea typeface="Times New Roman"/>
                 <a:cs typeface="Times New Roman"/>
               </a:rPr>
-              <a:t>0/10 placed coal on wind outlets</a:t>
+              <a:t>0/15 placed coal on wind outlets</a:t>
             </a:r>
           </a:p>
           <a:p>
@@ -17444,7 +17460,7 @@
                 <a:ea typeface="Times New Roman"/>
                 <a:cs typeface="Times New Roman"/>
               </a:rPr>
-              <a:t>Score range 51–88 (mean ≈ 80.2); carbon 0–1440 t (mean ≈ 273)</a:t>
+              <a:t>Score range 51–88 (mean ≈ 76.9); carbon 0–1440 t (mean ≈ 438)</a:t>
             </a:r>
           </a:p>
           <a:p>
@@ -17460,7 +17476,23 @@
                 <a:ea typeface="Times New Roman"/>
                 <a:cs typeface="Times New Roman"/>
               </a:rPr>
-              <a:t>Pattern: lower carbon (0–120 t, n=7) → scores 84–88; higher carbon (240–1440 t, n=3) → scores 51–81</a:t>
+              <a:t>Low carbon (0–120 t, n=9): scores mostly 84–88; high carbon (240–1440 t, n=6): scores 51–81</a:t>
+            </a:r>
+          </a:p>
+          <a:p>
+            <a:pPr marL="171450" indent="-171450">
+              <a:lnSpc>
+                <a:spcPct val="115000"/>
+              </a:lnSpc>
+              <a:buChar char="●"/>
+            </a:pPr>
+            <a:r>
+              <a:rPr lang="en-US" sz="1500" dirty="0">
+                <a:latin typeface="Times New Roman"/>
+                <a:ea typeface="Times New Roman"/>
+                <a:cs typeface="Times New Roman"/>
+              </a:rPr>
+              <a:t>Pre/post subset (n=5): cognition 3/4 → 3/4 (no change in this subset)</a:t>
             </a:r>
           </a:p>
           <a:p>
@@ -17647,7 +17679,7 @@
                 <a:latin typeface="Times New Roman"/>
                 <a:ea typeface="Times New Roman"/>
               </a:rPr>
-              <a:t>Takeaway: Budget pressure was common (8/10), but facility mix—not stated motivation alone—drove carbon outcomes. Short browser play can teach tradeoffs textbooks alone cannot show.</a:t>
+              <a:t>Takeaway: Budget pressure common (11/15), but facility mix drives emissions. 4/15 chose zero-coal layouts.</a:t>
             </a:r>
           </a:p>
         </p:txBody>
@@ -18238,7 +18270,7 @@
                 <a:ea typeface="Times New Roman"/>
                 <a:cs typeface="Times New Roman"/>
               </a:rPr>
-              <a:t>Budget pressure remains salient (8/10), yet 2/10 chose zero-coal wind layouts</a:t>
+              <a:t>Budget pressure remains salient (11/15), yet 4/15 chose zero-coal wind layouts</a:t>
             </a:r>
           </a:p>
           <a:p>
@@ -18441,7 +18473,7 @@
                 <a:latin typeface="Times New Roman"/>
                 <a:ea typeface="Times New Roman"/>
               </a:rPr>
-              <a:t>Takeaway: The pilot supports ventilation learning and safer siting, but N=10 limits generalization. Next: pre-register outcomes, expand the sample, and test advisory conditions.</a:t>
+              <a:t>Takeaway: Pilot supports ventilation learning and safer siting; N=15 exploratory sessions. Pre/post flow now live for future waves.</a:t>
             </a:r>
           </a:p>
         </p:txBody>
@@ -19032,7 +19064,7 @@
                 <a:ea typeface="Times New Roman"/>
                 <a:cs typeface="Times New Roman"/>
               </a:rPr>
-              <a:t>Limitations: N=10, simplified rule-based model, exploratory pilot—not confirmatory evidence</a:t>
+              <a:t>Limitations: N=15, simplified rule-based model, exploratory pilot—not confirmatory evidence</a:t>
             </a:r>
           </a:p>
           <a:p>
@@ -19048,7 +19080,7 @@
                 <a:ea typeface="Times New Roman"/>
                 <a:cs typeface="Times New Roman"/>
               </a:rPr>
-              <a:t>Future work: pre-register outcomes, expand sample size, test alternative advisory conditions</a:t>
+              <a:t>Future work: pre-register outcomes, expand independent participants, test advisory conditions</a:t>
             </a:r>
           </a:p>
         </p:txBody>

</xml_diff>